<commit_message>
courseware: rebuild W05 and W14 decks
</commit_message>
<xml_diff>
--- a/courseware/202609_ADS_W05_October_Exam_Review.pptx
+++ b/courseware/202609_ADS_W05_October_Exam_Review.pptx
@@ -4613,7 +4613,7 @@
                 <a:latin typeface="Segoe UI"/>
                 <a:ea typeface="微软雅黑"/>
               </a:rPr>
-              <a:t>T1 成绩转换（15 分）</a:t>
+              <a:t>T1 成绩转换</a:t>
             </a:r>
           </a:p>
         </p:txBody>
@@ -5467,7 +5467,7 @@
                 <a:latin typeface="Segoe UI"/>
                 <a:ea typeface="微软雅黑"/>
               </a:rPr>
-              <a:t>T2 单词首字母大写（15 分）</a:t>
+              <a:t>T2 单词首字母大写</a:t>
             </a:r>
           </a:p>
         </p:txBody>
@@ -6069,7 +6069,7 @@
                 <a:latin typeface="Segoe UI"/>
                 <a:ea typeface="微软雅黑"/>
               </a:rPr>
-              <a:t>T3 图书借阅排行（15 分）</a:t>
+              <a:t>T3 图书借阅排行</a:t>
             </a:r>
           </a:p>
         </p:txBody>
@@ -6556,7 +6556,7 @@
                 <a:latin typeface="Segoe UI"/>
                 <a:ea typeface="微软雅黑"/>
               </a:rPr>
-              <a:t>T4 区间内的 T-数（15 分）</a:t>
+              <a:t>T4 区间内的 T-数</a:t>
             </a:r>
           </a:p>
         </p:txBody>
@@ -7457,7 +7457,7 @@
                 <a:latin typeface="Segoe UI"/>
                 <a:ea typeface="微软雅黑"/>
               </a:rPr>
-              <a:t>T5 电梯调度模拟（20 分）</a:t>
+              <a:t>T5 电梯调度模拟</a:t>
             </a:r>
           </a:p>
         </p:txBody>
@@ -8128,7 +8128,7 @@
                 <a:latin typeface="Segoe UI"/>
                 <a:ea typeface="微软雅黑"/>
               </a:rPr>
-              <a:t>T6 补码计算器（20 分）</a:t>
+              <a:t>T6 补码计算器</a:t>
             </a:r>
           </a:p>
         </p:txBody>
@@ -18870,14 +18870,14 @@
               </a:spcAft>
             </a:pPr>
             <a:r>
-              <a:rPr sz="1800" b="1" i="0">
+              <a:rPr sz="2200" b="1" i="0">
                 <a:solidFill>
                   <a:srgbClr val="12395B"/>
                 </a:solidFill>
                 <a:latin typeface="Segoe UI"/>
                 <a:ea typeface="微软雅黑"/>
               </a:rPr>
-              <a:t>三次月考与期末上机考试都是 6 题 / 112 分钟 / 100 分，分值一律 15+15+15+15+20+20。月考不是缩水版，是同构演练。</a:t>
+              <a:t>三次月考与期末上机考试都是 6 题 / 112 分钟。月考不是缩水版，是同构演练。</a:t>
             </a:r>
           </a:p>
         </p:txBody>

</xml_diff>